<commit_message>
Use generic name and registration number placeholders
Co-Authored-By: Claude Sonnet 5.5 <noreply@anthropic.com>
Claude-Session: https://claude.ai/code/session_01PxJg5Kdj3DxQWxYBUBsz7B
</commit_message>
<xml_diff>
--- a/submission/Review3_Final_Presentation.pptx
+++ b/submission/Review3_Final_Presentation.pptx
@@ -3814,7 +3814,7 @@
                 </a:solidFill>
                 <a:latin typeface="Calibri"/>
               </a:rPr>
-              <a:t>Team: Pavitran VC [Reg. No.]  |  [Teammate name] [Reg. No.]</a:t>
+              <a:t>Team: [Your Name] [Reg. No.]  |  [Teammate Name] [Reg. No.]</a:t>
             </a:r>
           </a:p>
           <a:p>
@@ -3830,7 +3830,7 @@
                 </a:solidFill>
                 <a:latin typeface="Calibri"/>
               </a:rPr>
-              <a:t>Guide: [Name, designation]   |   Review 3 - Final Project, 26-30 Oct 2026</a:t>
+              <a:t>Guide: [Guide Name, Designation]   |   Review 3 - Final Project, 26-30 Oct 2026</a:t>
             </a:r>
           </a:p>
         </p:txBody>

</xml_diff>

<commit_message>
submission: update test counts and bug-audit summary after the hardening fixes
Review 2 is left unchanged (it describes the earlier version).

Co-Authored-By: Claude Sonnet 5.5 <noreply@anthropic.com>
Claude-Session: https://claude.ai/code/session_015fS3ThmfsSxmYP7DLEhG2y
</commit_message>
<xml_diff>
--- a/submission/Review3_Final_Presentation.pptx
+++ b/submission/Review3_Final_Presentation.pptx
@@ -7469,7 +7469,7 @@
                 </a:solidFill>
                 <a:latin typeface="Calibri"/>
               </a:rPr>
-              <a:t>158</a:t>
+              <a:t>171</a:t>
             </a:r>
           </a:p>
         </p:txBody>
@@ -8753,7 +8753,7 @@
                             <a:srgbClr val="222B36"/>
                           </a:solidFill>
                         </a:rPr>
-                        <a:t>24 unit binaries / 158 cases</a:t>
+                        <a:t>26 unit binaries / 171 cases</a:t>
                       </a:r>
                     </a:p>
                   </a:txBody>

</xml_diff>

<commit_message>
submission: plainer wording for the audit summary, ASCII bullets in the slides
Co-Authored-By: Claude Sonnet 5.5 <noreply@anthropic.com>
Claude-Session: https://claude.ai/code/session_015fS3ThmfsSxmYP7DLEhG2y
</commit_message>
<xml_diff>
--- a/submission/Review3_Final_Presentation.pptx
+++ b/submission/Review3_Final_Presentation.pptx
@@ -4047,7 +4047,7 @@
                 </a:solidFill>
                 <a:latin typeface="Calibri"/>
               </a:rPr>
-              <a:t>• Ground-truth sidecar: </a:t>
+              <a:t>- Ground-truth sidecar: </a:t>
             </a:r>
             <a:r>
               <a:rPr sz="1700">
@@ -4072,7 +4072,7 @@
                 </a:solidFill>
                 <a:latin typeface="Calibri"/>
               </a:rPr>
-              <a:t>• Adaptive ladder </a:t>
+              <a:t>- Adaptive ladder </a:t>
             </a:r>
             <a:r>
               <a:rPr sz="1700">
@@ -4097,7 +4097,7 @@
                 </a:solidFill>
                 <a:latin typeface="Calibri"/>
               </a:rPr>
-              <a:t>• Rigour: </a:t>
+              <a:t>- Rigour: </a:t>
             </a:r>
             <a:r>
               <a:rPr sz="1700">
@@ -4122,7 +4122,7 @@
                 </a:solidFill>
                 <a:latin typeface="Calibri"/>
               </a:rPr>
-              <a:t>• One library, </a:t>
+              <a:t>- One library, </a:t>
             </a:r>
             <a:r>
               <a:rPr sz="1700">
@@ -4209,7 +4209,7 @@
                 </a:solidFill>
                 <a:latin typeface="Calibri"/>
               </a:rPr>
-              <a:t>• Electronic toll collection at speed</a:t>
+              <a:t>- Electronic toll collection at speed</a:t>
             </a:r>
           </a:p>
           <a:p>
@@ -4225,7 +4225,7 @@
                 </a:solidFill>
                 <a:latin typeface="Calibri"/>
               </a:rPr>
-              <a:t>• Hospital / MRI and industrial impulsive-noise links</a:t>
+              <a:t>- Hospital / MRI and industrial impulsive-noise links</a:t>
             </a:r>
           </a:p>
           <a:p>
@@ -4241,7 +4241,7 @@
                 </a:solidFill>
                 <a:latin typeface="Calibri"/>
               </a:rPr>
-              <a:t>• Vehicle-to-infrastructure and RFID readers</a:t>
+              <a:t>- Vehicle-to-infrastructure and RFID readers</a:t>
             </a:r>
           </a:p>
           <a:p>
@@ -4257,7 +4257,7 @@
                 </a:solidFill>
                 <a:latin typeface="Calibri"/>
               </a:rPr>
-              <a:t>• Teaching reference for FEC vs ARQ vs HARQ trade-offs</a:t>
+              <a:t>- Teaching reference for FEC vs ARQ vs HARQ trade-offs</a:t>
             </a:r>
           </a:p>
         </p:txBody>
@@ -4474,7 +4474,7 @@
                 </a:solidFill>
                 <a:latin typeface="Calibri"/>
               </a:rPr>
-              <a:t>• CRC-protected FEC is safe: no wrong ID in 1,395,000 frames per profile.</a:t>
+              <a:t>- CRC-protected FEC is safe: no wrong ID in 1,395,000 frames per profile.</a:t>
             </a:r>
           </a:p>
           <a:p>
@@ -4490,7 +4490,7 @@
                 </a:solidFill>
                 <a:latin typeface="Calibri"/>
               </a:rPr>
-              <a:t>• Best code depends on the noise: BCH for random errors, Reed-Solomon or interleaving for bursts.</a:t>
+              <a:t>- Best code depends on the noise: BCH for random errors, Reed-Solomon or interleaving for bursts.</a:t>
             </a:r>
           </a:p>
           <a:p>
@@ -4506,7 +4506,7 @@
                 </a:solidFill>
                 <a:latin typeface="Calibri"/>
               </a:rPr>
-              <a:t>• FEC + feedback clearly beats pure retransmission: success 0.82 -&gt; ~1.00, p99 94 -&gt; 33 ms.</a:t>
+              <a:t>- FEC + feedback clearly beats pure retransmission: success 0.82 -&gt; ~1.00, p99 94 -&gt; 33 ms.</a:t>
             </a:r>
           </a:p>
           <a:p>
@@ -4522,7 +4522,7 @@
                 </a:solidFill>
                 <a:latin typeface="Calibri"/>
               </a:rPr>
-              <a:t>• Adaptive FEC tracks the channel but a strong fixed HARQ + RS t=4 wins on goodput - ladder design matters more than control logic.</a:t>
+              <a:t>- Adaptive FEC tracks the channel but a strong fixed HARQ + RS t=4 wins on goodput - ladder design matters more than control logic.</a:t>
             </a:r>
           </a:p>
         </p:txBody>
@@ -4778,7 +4778,7 @@
                 </a:solidFill>
                 <a:latin typeface="Calibri"/>
               </a:rPr>
-              <a:t>• Header CRC-16 </a:t>
+              <a:t>- Header CRC-16 </a:t>
             </a:r>
             <a:r>
               <a:rPr sz="2000">
@@ -4803,7 +4803,7 @@
                 </a:solidFill>
                 <a:latin typeface="Calibri"/>
               </a:rPr>
-              <a:t>• Type II HARQ </a:t>
+              <a:t>- Type II HARQ </a:t>
             </a:r>
             <a:r>
               <a:rPr sz="2000">
@@ -4828,7 +4828,7 @@
                 </a:solidFill>
                 <a:latin typeface="Calibri"/>
               </a:rPr>
-              <a:t>• Smarter controller: </a:t>
+              <a:t>- Smarter controller: </a:t>
             </a:r>
             <a:r>
               <a:rPr sz="2000">
@@ -4853,7 +4853,7 @@
                 </a:solidFill>
                 <a:latin typeface="Calibri"/>
               </a:rPr>
-              <a:t>• Real-world validation: </a:t>
+              <a:t>- Real-world validation: </a:t>
             </a:r>
             <a:r>
               <a:rPr sz="2000">
@@ -4878,7 +4878,7 @@
                 </a:solidFill>
                 <a:latin typeface="Calibri"/>
               </a:rPr>
-              <a:t>• Outcome: </a:t>
+              <a:t>- Outcome: </a:t>
             </a:r>
             <a:r>
               <a:rPr sz="2000">
@@ -5143,7 +5143,7 @@
                 </a:solidFill>
                 <a:latin typeface="Calibri"/>
               </a:rPr>
-              <a:t>• A toll unit must read a vehicle's 96-bit RFID tag ID in passing.</a:t>
+              <a:t>- A toll unit must read a vehicle's 96-bit RFID tag ID in passing.</a:t>
             </a:r>
           </a:p>
           <a:p>
@@ -5159,7 +5159,7 @@
                 </a:solidFill>
                 <a:latin typeface="Calibri"/>
               </a:rPr>
-              <a:t>• The wireless channel is noisy: random flips plus bursts (trucks, other readers, MRI/CT equipment).</a:t>
+              <a:t>- The wireless channel is noisy: random flips plus bursts (trucks, other readers, MRI/CT equipment).</a:t>
             </a:r>
           </a:p>
           <a:p>
@@ -5175,7 +5175,7 @@
                 </a:solidFill>
                 <a:latin typeface="Calibri"/>
               </a:rPr>
-              <a:t>• Retransmission costs a round trip the vehicle may not have; a wrong ID means a wrong charge.</a:t>
+              <a:t>- Retransmission costs a round trip the vehicle may not have; a wrong ID means a wrong charge.</a:t>
             </a:r>
           </a:p>
         </p:txBody>
@@ -5253,7 +5253,7 @@
                 </a:solidFill>
                 <a:latin typeface="Calibri"/>
               </a:rPr>
-              <a:t>• Implement Hamming, SECDED, BCH, Reed-Solomon, LDPC and CRC-32 from scratch (C11).</a:t>
+              <a:t>- Implement Hamming, SECDED, BCH, Reed-Solomon, LDPC and CRC-32 from scratch (C11).</a:t>
             </a:r>
           </a:p>
           <a:p>
@@ -5269,7 +5269,7 @@
                 </a:solidFill>
                 <a:latin typeface="Calibri"/>
               </a:rPr>
-              <a:t>• Model BSC, Gilbert-Elliott and burst noise in two profiles: toll plaza, hospital imaging.</a:t>
+              <a:t>- Model BSC, Gilbert-Elliott and burst noise in two profiles: toll plaza, hospital imaging.</a:t>
             </a:r>
           </a:p>
           <a:p>
@@ -5285,7 +5285,7 @@
                 </a:solidFill>
                 <a:latin typeface="Calibri"/>
               </a:rPr>
-              <a:t>• Build a real 3-process UDP link with feedback.</a:t>
+              <a:t>- Build a real 3-process UDP link with feedback.</a:t>
             </a:r>
           </a:p>
           <a:p>
@@ -5301,7 +5301,7 @@
                 </a:solidFill>
                 <a:latin typeface="Calibri"/>
               </a:rPr>
-              <a:t>• Compare FEC, ARQ, HARQ and an adaptive controller with 20-seed statistics.</a:t>
+              <a:t>- Compare FEC, ARQ, HARQ and an adaptive controller with 20-seed statistics.</a:t>
             </a:r>
           </a:p>
           <a:p>
@@ -5317,7 +5317,7 @@
                 </a:solidFill>
                 <a:latin typeface="Calibri"/>
               </a:rPr>
-              <a:t>• Never accept a wrong ID silently.</a:t>
+              <a:t>- Never accept a wrong ID silently.</a:t>
             </a:r>
           </a:p>
         </p:txBody>
@@ -5534,7 +5534,7 @@
                 </a:solidFill>
                 <a:latin typeface="Calibri"/>
               </a:rPr>
-              <a:t>• Correct in place: </a:t>
+              <a:t>- Correct in place: </a:t>
             </a:r>
             <a:r>
               <a:rPr sz="1800">
@@ -5559,7 +5559,7 @@
                 </a:solidFill>
                 <a:latin typeface="Calibri"/>
               </a:rPr>
-              <a:t>• End-to-end safety: </a:t>
+              <a:t>- End-to-end safety: </a:t>
             </a:r>
             <a:r>
               <a:rPr sz="1800">
@@ -5584,7 +5584,7 @@
                 </a:solidFill>
                 <a:latin typeface="Calibri"/>
               </a:rPr>
-              <a:t>• Right code for the noise: </a:t>
+              <a:t>- Right code for the noise: </a:t>
             </a:r>
             <a:r>
               <a:rPr sz="1800">
@@ -5609,7 +5609,7 @@
                 </a:solidFill>
                 <a:latin typeface="Calibri"/>
               </a:rPr>
-              <a:t>• Hybrid ARQ: </a:t>
+              <a:t>- Hybrid ARQ: </a:t>
             </a:r>
             <a:r>
               <a:rPr sz="1800">
@@ -5634,7 +5634,7 @@
                 </a:solidFill>
                 <a:latin typeface="Calibri"/>
               </a:rPr>
-              <a:t>• Adaptive ladder: </a:t>
+              <a:t>- Adaptive ladder: </a:t>
             </a:r>
             <a:r>
               <a:rPr sz="1800">
@@ -6641,7 +6641,7 @@
                 </a:solidFill>
                 <a:latin typeface="Calibri"/>
               </a:rPr>
-              <a:t>• Codes: </a:t>
+              <a:t>- Codes: </a:t>
             </a:r>
             <a:r>
               <a:rPr sz="1600">
@@ -6666,7 +6666,7 @@
                 </a:solidFill>
                 <a:latin typeface="Calibri"/>
               </a:rPr>
-              <a:t>• Noise: </a:t>
+              <a:t>- Noise: </a:t>
             </a:r>
             <a:r>
               <a:rPr sz="1600">
@@ -6691,7 +6691,7 @@
                 </a:solidFill>
                 <a:latin typeface="Calibri"/>
               </a:rPr>
-              <a:t>• Metrics: </a:t>
+              <a:t>- Metrics: </a:t>
             </a:r>
             <a:r>
               <a:rPr sz="1600">
@@ -6716,7 +6716,7 @@
                 </a:solidFill>
                 <a:latin typeface="Calibri"/>
               </a:rPr>
-              <a:t>• Statistics: </a:t>
+              <a:t>- Statistics: </a:t>
             </a:r>
             <a:r>
               <a:rPr sz="1600">
@@ -6741,7 +6741,7 @@
                 </a:solidFill>
                 <a:latin typeface="Calibri"/>
               </a:rPr>
-              <a:t>• Pre-registered </a:t>
+              <a:t>- Pre-registered </a:t>
             </a:r>
             <a:r>
               <a:rPr sz="1600">

</xml_diff>